<commit_message>
Redesign last slide: replace closing with summary + Q&A layout
Replace title-like closing slide with a proper ending slide featuring
3 summary cards (AI analysis, architecture, tradition+tech) and a Q&A banner.

https://claude.ai/code/session_018VNmPm52C92EX5i5DoqY3B
</commit_message>
<xml_diff>
--- a/saju_app_overview.pptx
+++ b/saju_app_overview.pptx
@@ -4637,7 +4637,7 @@
                   <a:srgbClr val="CCDDFF"/>
                 </a:solidFill>
               </a:rPr>
-              <a:t>●  성격 및 운세 — 건강운·재물운·애정운·직업운 (올해 2026년 기준)</a:t>
+              <a:t>●  성격 및 운세 — 건강운·재물운·애정운·직업운 (2026년 기준)</a:t>
             </a:r>
           </a:p>
         </p:txBody>
@@ -5937,7 +5937,629 @@
         <p:spPr>
           <a:xfrm>
             <a:off x="0" y="0"/>
-            <a:ext cx="12188952" cy="6858000"/>
+            <a:ext cx="12188952" cy="1005840"/>
+          </a:xfrm>
+          <a:prstGeom prst="rect">
+            <a:avLst/>
+          </a:prstGeom>
+          <a:solidFill>
+            <a:srgbClr val="101830"/>
+          </a:solidFill>
+          <a:ln>
+            <a:noFill/>
+          </a:ln>
+        </p:spPr>
+        <p:style>
+          <a:lnRef idx="1">
+            <a:schemeClr val="accent1"/>
+          </a:lnRef>
+          <a:fillRef idx="3">
+            <a:schemeClr val="accent1"/>
+          </a:fillRef>
+          <a:effectRef idx="2">
+            <a:schemeClr val="accent1"/>
+          </a:effectRef>
+          <a:fontRef idx="minor">
+            <a:schemeClr val="lt1"/>
+          </a:fontRef>
+        </p:style>
+        <p:txBody>
+          <a:bodyPr rtlCol="0" anchor="ctr"/>
+          <a:lstStyle/>
+          <a:p>
+            <a:pPr algn="ctr"/>
+          </a:p>
+        </p:txBody>
+      </p:sp>
+      <p:sp>
+        <p:nvSpPr>
+          <p:cNvPr id="3" name="Rectangle 2"/>
+          <p:cNvSpPr/>
+          <p:nvPr/>
+        </p:nvSpPr>
+        <p:spPr>
+          <a:xfrm>
+            <a:off x="0" y="0"/>
+            <a:ext cx="73152" cy="6858000"/>
+          </a:xfrm>
+          <a:prstGeom prst="rect">
+            <a:avLst/>
+          </a:prstGeom>
+          <a:solidFill>
+            <a:srgbClr val="F5C518"/>
+          </a:solidFill>
+          <a:ln>
+            <a:noFill/>
+          </a:ln>
+        </p:spPr>
+        <p:style>
+          <a:lnRef idx="1">
+            <a:schemeClr val="accent1"/>
+          </a:lnRef>
+          <a:fillRef idx="3">
+            <a:schemeClr val="accent1"/>
+          </a:fillRef>
+          <a:effectRef idx="2">
+            <a:schemeClr val="accent1"/>
+          </a:effectRef>
+          <a:fontRef idx="minor">
+            <a:schemeClr val="lt1"/>
+          </a:fontRef>
+        </p:style>
+        <p:txBody>
+          <a:bodyPr rtlCol="0" anchor="ctr"/>
+          <a:lstStyle/>
+          <a:p>
+            <a:pPr algn="ctr"/>
+          </a:p>
+        </p:txBody>
+      </p:sp>
+      <p:sp>
+        <p:nvSpPr>
+          <p:cNvPr id="4" name="TextBox 3"/>
+          <p:cNvSpPr txBox="1"/>
+          <p:nvPr/>
+        </p:nvSpPr>
+        <p:spPr>
+          <a:xfrm>
+            <a:off x="274320" y="164592"/>
+            <a:ext cx="7315200" cy="685800"/>
+          </a:xfrm>
+          <a:prstGeom prst="rect">
+            <a:avLst/>
+          </a:prstGeom>
+          <a:noFill/>
+        </p:spPr>
+        <p:txBody>
+          <a:bodyPr wrap="square">
+            <a:spAutoFit/>
+          </a:bodyPr>
+          <a:lstStyle/>
+          <a:p>
+            <a:pPr algn="l"/>
+            <a:r>
+              <a:rPr sz="2800" b="1" i="0">
+                <a:solidFill>
+                  <a:srgbClr val="F5C518"/>
+                </a:solidFill>
+              </a:rPr>
+              <a:t>핵심 요약</a:t>
+            </a:r>
+          </a:p>
+        </p:txBody>
+      </p:sp>
+      <p:sp>
+        <p:nvSpPr>
+          <p:cNvPr id="5" name="TextBox 4"/>
+          <p:cNvSpPr txBox="1"/>
+          <p:nvPr/>
+        </p:nvSpPr>
+        <p:spPr>
+          <a:xfrm>
+            <a:off x="9601200" y="201168"/>
+            <a:ext cx="2286000" cy="548640"/>
+          </a:xfrm>
+          <a:prstGeom prst="rect">
+            <a:avLst/>
+          </a:prstGeom>
+          <a:noFill/>
+        </p:spPr>
+        <p:txBody>
+          <a:bodyPr wrap="square">
+            <a:spAutoFit/>
+          </a:bodyPr>
+          <a:lstStyle/>
+          <a:p>
+            <a:pPr algn="r"/>
+            <a:r>
+              <a:rPr sz="1800" b="0" i="0">
+                <a:solidFill>
+                  <a:srgbClr val="8899BB"/>
+                </a:solidFill>
+              </a:rPr>
+              <a:t>08 / 08</a:t>
+            </a:r>
+          </a:p>
+        </p:txBody>
+      </p:sp>
+      <p:sp>
+        <p:nvSpPr>
+          <p:cNvPr id="6" name="Rectangle 5"/>
+          <p:cNvSpPr/>
+          <p:nvPr/>
+        </p:nvSpPr>
+        <p:spPr>
+          <a:xfrm>
+            <a:off x="365760" y="1188720"/>
+            <a:ext cx="3566160" cy="3108960"/>
+          </a:xfrm>
+          <a:prstGeom prst="rect">
+            <a:avLst/>
+          </a:prstGeom>
+          <a:solidFill>
+            <a:srgbClr val="2A1B3D"/>
+          </a:solidFill>
+          <a:ln>
+            <a:noFill/>
+          </a:ln>
+        </p:spPr>
+        <p:style>
+          <a:lnRef idx="1">
+            <a:schemeClr val="accent1"/>
+          </a:lnRef>
+          <a:fillRef idx="3">
+            <a:schemeClr val="accent1"/>
+          </a:fillRef>
+          <a:effectRef idx="2">
+            <a:schemeClr val="accent1"/>
+          </a:effectRef>
+          <a:fontRef idx="minor">
+            <a:schemeClr val="lt1"/>
+          </a:fontRef>
+        </p:style>
+        <p:txBody>
+          <a:bodyPr rtlCol="0" anchor="ctr"/>
+          <a:lstStyle/>
+          <a:p>
+            <a:pPr algn="ctr"/>
+          </a:p>
+        </p:txBody>
+      </p:sp>
+      <p:sp>
+        <p:nvSpPr>
+          <p:cNvPr id="7" name="Rectangle 6"/>
+          <p:cNvSpPr/>
+          <p:nvPr/>
+        </p:nvSpPr>
+        <p:spPr>
+          <a:xfrm>
+            <a:off x="365760" y="1188720"/>
+            <a:ext cx="3566160" cy="502920"/>
+          </a:xfrm>
+          <a:prstGeom prst="rect">
+            <a:avLst/>
+          </a:prstGeom>
+          <a:solidFill>
+            <a:srgbClr val="E94F37"/>
+          </a:solidFill>
+          <a:ln>
+            <a:noFill/>
+          </a:ln>
+        </p:spPr>
+        <p:style>
+          <a:lnRef idx="1">
+            <a:schemeClr val="accent1"/>
+          </a:lnRef>
+          <a:fillRef idx="3">
+            <a:schemeClr val="accent1"/>
+          </a:fillRef>
+          <a:effectRef idx="2">
+            <a:schemeClr val="accent1"/>
+          </a:effectRef>
+          <a:fontRef idx="minor">
+            <a:schemeClr val="lt1"/>
+          </a:fontRef>
+        </p:style>
+        <p:txBody>
+          <a:bodyPr rtlCol="0" anchor="ctr"/>
+          <a:lstStyle/>
+          <a:p>
+            <a:pPr algn="ctr"/>
+          </a:p>
+        </p:txBody>
+      </p:sp>
+      <p:sp>
+        <p:nvSpPr>
+          <p:cNvPr id="8" name="TextBox 7"/>
+          <p:cNvSpPr txBox="1"/>
+          <p:nvPr/>
+        </p:nvSpPr>
+        <p:spPr>
+          <a:xfrm>
+            <a:off x="502920" y="1234440"/>
+            <a:ext cx="3291840" cy="457200"/>
+          </a:xfrm>
+          <a:prstGeom prst="rect">
+            <a:avLst/>
+          </a:prstGeom>
+          <a:noFill/>
+        </p:spPr>
+        <p:txBody>
+          <a:bodyPr wrap="square">
+            <a:spAutoFit/>
+          </a:bodyPr>
+          <a:lstStyle/>
+          <a:p>
+            <a:pPr algn="l"/>
+            <a:r>
+              <a:rPr sz="1600" b="1" i="0">
+                <a:solidFill>
+                  <a:srgbClr val="FFFFFF"/>
+                </a:solidFill>
+              </a:rPr>
+              <a:t>AI 기반 분석</a:t>
+            </a:r>
+          </a:p>
+        </p:txBody>
+      </p:sp>
+      <p:sp>
+        <p:nvSpPr>
+          <p:cNvPr id="9" name="TextBox 8"/>
+          <p:cNvSpPr txBox="1"/>
+          <p:nvPr/>
+        </p:nvSpPr>
+        <p:spPr>
+          <a:xfrm>
+            <a:off x="502920" y="1828800"/>
+            <a:ext cx="3291840" cy="1645920"/>
+          </a:xfrm>
+          <a:prstGeom prst="rect">
+            <a:avLst/>
+          </a:prstGeom>
+          <a:noFill/>
+        </p:spPr>
+        <p:txBody>
+          <a:bodyPr wrap="square">
+            <a:spAutoFit/>
+          </a:bodyPr>
+          <a:lstStyle/>
+          <a:p>
+            <a:pPr algn="l"/>
+            <a:r>
+              <a:rPr sz="1500" b="0" i="0">
+                <a:solidFill>
+                  <a:srgbClr val="CCDDFF"/>
+                </a:solidFill>
+              </a:rPr>
+              <a:t>Claude Sonnet 4.6
+사주팔자·오행·운세
+실시간 스트리밍</a:t>
+            </a:r>
+          </a:p>
+        </p:txBody>
+      </p:sp>
+      <p:sp>
+        <p:nvSpPr>
+          <p:cNvPr id="10" name="Rectangle 9"/>
+          <p:cNvSpPr/>
+          <p:nvPr/>
+        </p:nvSpPr>
+        <p:spPr>
+          <a:xfrm>
+            <a:off x="4297680" y="1188720"/>
+            <a:ext cx="3566160" cy="3108960"/>
+          </a:xfrm>
+          <a:prstGeom prst="rect">
+            <a:avLst/>
+          </a:prstGeom>
+          <a:solidFill>
+            <a:srgbClr val="1B3A2F"/>
+          </a:solidFill>
+          <a:ln>
+            <a:noFill/>
+          </a:ln>
+        </p:spPr>
+        <p:style>
+          <a:lnRef idx="1">
+            <a:schemeClr val="accent1"/>
+          </a:lnRef>
+          <a:fillRef idx="3">
+            <a:schemeClr val="accent1"/>
+          </a:fillRef>
+          <a:effectRef idx="2">
+            <a:schemeClr val="accent1"/>
+          </a:effectRef>
+          <a:fontRef idx="minor">
+            <a:schemeClr val="lt1"/>
+          </a:fontRef>
+        </p:style>
+        <p:txBody>
+          <a:bodyPr rtlCol="0" anchor="ctr"/>
+          <a:lstStyle/>
+          <a:p>
+            <a:pPr algn="ctr"/>
+          </a:p>
+        </p:txBody>
+      </p:sp>
+      <p:sp>
+        <p:nvSpPr>
+          <p:cNvPr id="11" name="Rectangle 10"/>
+          <p:cNvSpPr/>
+          <p:nvPr/>
+        </p:nvSpPr>
+        <p:spPr>
+          <a:xfrm>
+            <a:off x="4297680" y="1188720"/>
+            <a:ext cx="3566160" cy="502920"/>
+          </a:xfrm>
+          <a:prstGeom prst="rect">
+            <a:avLst/>
+          </a:prstGeom>
+          <a:solidFill>
+            <a:srgbClr val="F5C518"/>
+          </a:solidFill>
+          <a:ln>
+            <a:noFill/>
+          </a:ln>
+        </p:spPr>
+        <p:style>
+          <a:lnRef idx="1">
+            <a:schemeClr val="accent1"/>
+          </a:lnRef>
+          <a:fillRef idx="3">
+            <a:schemeClr val="accent1"/>
+          </a:fillRef>
+          <a:effectRef idx="2">
+            <a:schemeClr val="accent1"/>
+          </a:effectRef>
+          <a:fontRef idx="minor">
+            <a:schemeClr val="lt1"/>
+          </a:fontRef>
+        </p:style>
+        <p:txBody>
+          <a:bodyPr rtlCol="0" anchor="ctr"/>
+          <a:lstStyle/>
+          <a:p>
+            <a:pPr algn="ctr"/>
+          </a:p>
+        </p:txBody>
+      </p:sp>
+      <p:sp>
+        <p:nvSpPr>
+          <p:cNvPr id="12" name="TextBox 11"/>
+          <p:cNvSpPr txBox="1"/>
+          <p:nvPr/>
+        </p:nvSpPr>
+        <p:spPr>
+          <a:xfrm>
+            <a:off x="4434840" y="1234440"/>
+            <a:ext cx="3291840" cy="457200"/>
+          </a:xfrm>
+          <a:prstGeom prst="rect">
+            <a:avLst/>
+          </a:prstGeom>
+          <a:noFill/>
+        </p:spPr>
+        <p:txBody>
+          <a:bodyPr wrap="square">
+            <a:spAutoFit/>
+          </a:bodyPr>
+          <a:lstStyle/>
+          <a:p>
+            <a:pPr algn="l"/>
+            <a:r>
+              <a:rPr sz="1600" b="1" i="0">
+                <a:solidFill>
+                  <a:srgbClr val="FFFFFF"/>
+                </a:solidFill>
+              </a:rPr>
+              <a:t>현대적 아키텍처</a:t>
+            </a:r>
+          </a:p>
+        </p:txBody>
+      </p:sp>
+      <p:sp>
+        <p:nvSpPr>
+          <p:cNvPr id="13" name="TextBox 12"/>
+          <p:cNvSpPr txBox="1"/>
+          <p:nvPr/>
+        </p:nvSpPr>
+        <p:spPr>
+          <a:xfrm>
+            <a:off x="4434840" y="1828800"/>
+            <a:ext cx="3291840" cy="1645920"/>
+          </a:xfrm>
+          <a:prstGeom prst="rect">
+            <a:avLst/>
+          </a:prstGeom>
+          <a:noFill/>
+        </p:spPr>
+        <p:txBody>
+          <a:bodyPr wrap="square">
+            <a:spAutoFit/>
+          </a:bodyPr>
+          <a:lstStyle/>
+          <a:p>
+            <a:pPr algn="l"/>
+            <a:r>
+              <a:rPr sz="1500" b="0" i="0">
+                <a:solidFill>
+                  <a:srgbClr val="CCDDFF"/>
+                </a:solidFill>
+              </a:rPr>
+              <a:t>Express.js + SSE
+Vercel 서버리스
+환경 변수 관리</a:t>
+            </a:r>
+          </a:p>
+        </p:txBody>
+      </p:sp>
+      <p:sp>
+        <p:nvSpPr>
+          <p:cNvPr id="14" name="Rectangle 13"/>
+          <p:cNvSpPr/>
+          <p:nvPr/>
+        </p:nvSpPr>
+        <p:spPr>
+          <a:xfrm>
+            <a:off x="8229600" y="1188720"/>
+            <a:ext cx="3566160" cy="3108960"/>
+          </a:xfrm>
+          <a:prstGeom prst="rect">
+            <a:avLst/>
+          </a:prstGeom>
+          <a:solidFill>
+            <a:srgbClr val="3A2010"/>
+          </a:solidFill>
+          <a:ln>
+            <a:noFill/>
+          </a:ln>
+        </p:spPr>
+        <p:style>
+          <a:lnRef idx="1">
+            <a:schemeClr val="accent1"/>
+          </a:lnRef>
+          <a:fillRef idx="3">
+            <a:schemeClr val="accent1"/>
+          </a:fillRef>
+          <a:effectRef idx="2">
+            <a:schemeClr val="accent1"/>
+          </a:effectRef>
+          <a:fontRef idx="minor">
+            <a:schemeClr val="lt1"/>
+          </a:fontRef>
+        </p:style>
+        <p:txBody>
+          <a:bodyPr rtlCol="0" anchor="ctr"/>
+          <a:lstStyle/>
+          <a:p>
+            <a:pPr algn="ctr"/>
+          </a:p>
+        </p:txBody>
+      </p:sp>
+      <p:sp>
+        <p:nvSpPr>
+          <p:cNvPr id="15" name="Rectangle 14"/>
+          <p:cNvSpPr/>
+          <p:nvPr/>
+        </p:nvSpPr>
+        <p:spPr>
+          <a:xfrm>
+            <a:off x="8229600" y="1188720"/>
+            <a:ext cx="3566160" cy="502920"/>
+          </a:xfrm>
+          <a:prstGeom prst="rect">
+            <a:avLst/>
+          </a:prstGeom>
+          <a:solidFill>
+            <a:srgbClr val="885522"/>
+          </a:solidFill>
+          <a:ln>
+            <a:noFill/>
+          </a:ln>
+        </p:spPr>
+        <p:style>
+          <a:lnRef idx="1">
+            <a:schemeClr val="accent1"/>
+          </a:lnRef>
+          <a:fillRef idx="3">
+            <a:schemeClr val="accent1"/>
+          </a:fillRef>
+          <a:effectRef idx="2">
+            <a:schemeClr val="accent1"/>
+          </a:effectRef>
+          <a:fontRef idx="minor">
+            <a:schemeClr val="lt1"/>
+          </a:fontRef>
+        </p:style>
+        <p:txBody>
+          <a:bodyPr rtlCol="0" anchor="ctr"/>
+          <a:lstStyle/>
+          <a:p>
+            <a:pPr algn="ctr"/>
+          </a:p>
+        </p:txBody>
+      </p:sp>
+      <p:sp>
+        <p:nvSpPr>
+          <p:cNvPr id="16" name="TextBox 15"/>
+          <p:cNvSpPr txBox="1"/>
+          <p:nvPr/>
+        </p:nvSpPr>
+        <p:spPr>
+          <a:xfrm>
+            <a:off x="8366760" y="1234440"/>
+            <a:ext cx="3291840" cy="457200"/>
+          </a:xfrm>
+          <a:prstGeom prst="rect">
+            <a:avLst/>
+          </a:prstGeom>
+          <a:noFill/>
+        </p:spPr>
+        <p:txBody>
+          <a:bodyPr wrap="square">
+            <a:spAutoFit/>
+          </a:bodyPr>
+          <a:lstStyle/>
+          <a:p>
+            <a:pPr algn="l"/>
+            <a:r>
+              <a:rPr sz="1600" b="1" i="0">
+                <a:solidFill>
+                  <a:srgbClr val="FFFFFF"/>
+                </a:solidFill>
+              </a:rPr>
+              <a:t>전통과 기술의 융합</a:t>
+            </a:r>
+          </a:p>
+        </p:txBody>
+      </p:sp>
+      <p:sp>
+        <p:nvSpPr>
+          <p:cNvPr id="17" name="TextBox 16"/>
+          <p:cNvSpPr txBox="1"/>
+          <p:nvPr/>
+        </p:nvSpPr>
+        <p:spPr>
+          <a:xfrm>
+            <a:off x="8366760" y="1828800"/>
+            <a:ext cx="3291840" cy="1645920"/>
+          </a:xfrm>
+          <a:prstGeom prst="rect">
+            <a:avLst/>
+          </a:prstGeom>
+          <a:noFill/>
+        </p:spPr>
+        <p:txBody>
+          <a:bodyPr wrap="square">
+            <a:spAutoFit/>
+          </a:bodyPr>
+          <a:lstStyle/>
+          <a:p>
+            <a:pPr algn="l"/>
+            <a:r>
+              <a:rPr sz="1500" b="0" i="0">
+                <a:solidFill>
+                  <a:srgbClr val="CCDDFF"/>
+                </a:solidFill>
+              </a:rPr>
+              <a:t>사주명리학 6개 분야
+따뜻한 톤의 분석
+실용적 개운법 제공</a:t>
+            </a:r>
+          </a:p>
+        </p:txBody>
+      </p:sp>
+      <p:sp>
+        <p:nvSpPr>
+          <p:cNvPr id="18" name="Rectangle 17"/>
+          <p:cNvSpPr/>
+          <p:nvPr/>
+        </p:nvSpPr>
+        <p:spPr>
+          <a:xfrm>
+            <a:off x="0" y="4572000"/>
+            <a:ext cx="12188952" cy="2286000"/>
           </a:xfrm>
           <a:prstGeom prst="rect">
             <a:avLst/>
@@ -5973,14 +6595,14 @@
       </p:sp>
       <p:sp>
         <p:nvSpPr>
-          <p:cNvPr id="3" name="Rectangle 2"/>
+          <p:cNvPr id="19" name="Rectangle 18"/>
           <p:cNvSpPr/>
           <p:nvPr/>
         </p:nvSpPr>
         <p:spPr>
           <a:xfrm>
-            <a:off x="0" y="0"/>
-            <a:ext cx="164592" cy="6858000"/>
+            <a:off x="0" y="4572000"/>
+            <a:ext cx="12188952" cy="45720"/>
           </a:xfrm>
           <a:prstGeom prst="rect">
             <a:avLst/>
@@ -6016,100 +6638,14 @@
       </p:sp>
       <p:sp>
         <p:nvSpPr>
-          <p:cNvPr id="4" name="Rectangle 3"/>
-          <p:cNvSpPr/>
-          <p:nvPr/>
-        </p:nvSpPr>
-        <p:spPr>
-          <a:xfrm>
-            <a:off x="164592" y="0"/>
-            <a:ext cx="73152" cy="6858000"/>
-          </a:xfrm>
-          <a:prstGeom prst="rect">
-            <a:avLst/>
-          </a:prstGeom>
-          <a:solidFill>
-            <a:srgbClr val="E94F37"/>
-          </a:solidFill>
-          <a:ln>
-            <a:noFill/>
-          </a:ln>
-        </p:spPr>
-        <p:style>
-          <a:lnRef idx="1">
-            <a:schemeClr val="accent1"/>
-          </a:lnRef>
-          <a:fillRef idx="3">
-            <a:schemeClr val="accent1"/>
-          </a:fillRef>
-          <a:effectRef idx="2">
-            <a:schemeClr val="accent1"/>
-          </a:effectRef>
-          <a:fontRef idx="minor">
-            <a:schemeClr val="lt1"/>
-          </a:fontRef>
-        </p:style>
-        <p:txBody>
-          <a:bodyPr rtlCol="0" anchor="ctr"/>
-          <a:lstStyle/>
-          <a:p>
-            <a:pPr algn="ctr"/>
-          </a:p>
-        </p:txBody>
-      </p:sp>
-      <p:sp>
-        <p:nvSpPr>
-          <p:cNvPr id="5" name="Rectangle 4"/>
-          <p:cNvSpPr/>
-          <p:nvPr/>
-        </p:nvSpPr>
-        <p:spPr>
-          <a:xfrm>
-            <a:off x="0" y="5303520"/>
-            <a:ext cx="12188952" cy="1554480"/>
-          </a:xfrm>
-          <a:prstGeom prst="rect">
-            <a:avLst/>
-          </a:prstGeom>
-          <a:solidFill>
-            <a:srgbClr val="101830"/>
-          </a:solidFill>
-          <a:ln>
-            <a:noFill/>
-          </a:ln>
-        </p:spPr>
-        <p:style>
-          <a:lnRef idx="1">
-            <a:schemeClr val="accent1"/>
-          </a:lnRef>
-          <a:fillRef idx="3">
-            <a:schemeClr val="accent1"/>
-          </a:fillRef>
-          <a:effectRef idx="2">
-            <a:schemeClr val="accent1"/>
-          </a:effectRef>
-          <a:fontRef idx="minor">
-            <a:schemeClr val="lt1"/>
-          </a:fontRef>
-        </p:style>
-        <p:txBody>
-          <a:bodyPr rtlCol="0" anchor="ctr"/>
-          <a:lstStyle/>
-          <a:p>
-            <a:pPr algn="ctr"/>
-          </a:p>
-        </p:txBody>
-      </p:sp>
-      <p:sp>
-        <p:nvSpPr>
-          <p:cNvPr id="6" name="TextBox 5"/>
+          <p:cNvPr id="20" name="TextBox 19"/>
           <p:cNvSpPr txBox="1"/>
           <p:nvPr/>
         </p:nvSpPr>
         <p:spPr>
           <a:xfrm>
-            <a:off x="548640" y="914400"/>
-            <a:ext cx="10972800" cy="914400"/>
+            <a:off x="274320" y="4846320"/>
+            <a:ext cx="11887200" cy="822960"/>
           </a:xfrm>
           <a:prstGeom prst="rect">
             <a:avLst/>
@@ -6124,26 +6660,26 @@
           <a:p>
             <a:pPr algn="ctr"/>
             <a:r>
-              <a:rPr sz="4800" b="0" i="0">
+              <a:rPr sz="4800" b="1" i="0">
                 <a:solidFill>
                   <a:srgbClr val="F5C518"/>
                 </a:solidFill>
               </a:rPr>
-              <a:t>✦</a:t>
-            </a:r>
-          </a:p>
-        </p:txBody>
-      </p:sp>
-      <p:sp>
-        <p:nvSpPr>
-          <p:cNvPr id="7" name="TextBox 6"/>
+              <a:t>Q &amp; A</a:t>
+            </a:r>
+          </a:p>
+        </p:txBody>
+      </p:sp>
+      <p:sp>
+        <p:nvSpPr>
+          <p:cNvPr id="21" name="TextBox 20"/>
           <p:cNvSpPr txBox="1"/>
           <p:nvPr/>
         </p:nvSpPr>
         <p:spPr>
           <a:xfrm>
-            <a:off x="548640" y="1920240"/>
-            <a:ext cx="10972800" cy="914400"/>
+            <a:off x="274320" y="5669280"/>
+            <a:ext cx="11887200" cy="548640"/>
           </a:xfrm>
           <a:prstGeom prst="rect">
             <a:avLst/>
@@ -6158,123 +6694,12 @@
           <a:p>
             <a:pPr algn="ctr"/>
             <a:r>
-              <a:rPr sz="3600" b="1" i="0">
-                <a:solidFill>
-                  <a:srgbClr val="FFFFFF"/>
+              <a:rPr sz="1800" b="0" i="1">
+                <a:solidFill>
+                  <a:srgbClr val="CCDDFF"/>
                 </a:solidFill>
               </a:rPr>
-              <a:t>사주 분석 웹 애플리케이션</a:t>
-            </a:r>
-          </a:p>
-        </p:txBody>
-      </p:sp>
-      <p:sp>
-        <p:nvSpPr>
-          <p:cNvPr id="8" name="TextBox 7"/>
-          <p:cNvSpPr txBox="1"/>
-          <p:nvPr/>
-        </p:nvSpPr>
-        <p:spPr>
-          <a:xfrm>
-            <a:off x="548640" y="2834640"/>
-            <a:ext cx="10972800" cy="640080"/>
-          </a:xfrm>
-          <a:prstGeom prst="rect">
-            <a:avLst/>
-          </a:prstGeom>
-          <a:noFill/>
-        </p:spPr>
-        <p:txBody>
-          <a:bodyPr wrap="square">
-            <a:spAutoFit/>
-          </a:bodyPr>
-          <a:lstStyle/>
-          <a:p>
-            <a:pPr algn="ctr"/>
-            <a:r>
-              <a:rPr sz="2200" b="0" i="1">
-                <a:solidFill>
-                  <a:srgbClr val="CCDDFF"/>
-                </a:solidFill>
-              </a:rPr>
-              <a:t>Claude AI 기반 전통 사주명리학의 현대적 구현</a:t>
-            </a:r>
-          </a:p>
-        </p:txBody>
-      </p:sp>
-      <p:sp>
-        <p:nvSpPr>
-          <p:cNvPr id="9" name="Rectangle 8"/>
-          <p:cNvSpPr/>
-          <p:nvPr/>
-        </p:nvSpPr>
-        <p:spPr>
-          <a:xfrm>
-            <a:off x="3657600" y="3657600"/>
-            <a:ext cx="4846320" cy="45720"/>
-          </a:xfrm>
-          <a:prstGeom prst="rect">
-            <a:avLst/>
-          </a:prstGeom>
-          <a:solidFill>
-            <a:srgbClr val="F5C518"/>
-          </a:solidFill>
-          <a:ln>
-            <a:noFill/>
-          </a:ln>
-        </p:spPr>
-        <p:style>
-          <a:lnRef idx="1">
-            <a:schemeClr val="accent1"/>
-          </a:lnRef>
-          <a:fillRef idx="3">
-            <a:schemeClr val="accent1"/>
-          </a:fillRef>
-          <a:effectRef idx="2">
-            <a:schemeClr val="accent1"/>
-          </a:effectRef>
-          <a:fontRef idx="minor">
-            <a:schemeClr val="lt1"/>
-          </a:fontRef>
-        </p:style>
-        <p:txBody>
-          <a:bodyPr rtlCol="0" anchor="ctr"/>
-          <a:lstStyle/>
-          <a:p>
-            <a:pPr algn="ctr"/>
-          </a:p>
-        </p:txBody>
-      </p:sp>
-      <p:sp>
-        <p:nvSpPr>
-          <p:cNvPr id="10" name="TextBox 9"/>
-          <p:cNvSpPr txBox="1"/>
-          <p:nvPr/>
-        </p:nvSpPr>
-        <p:spPr>
-          <a:xfrm>
-            <a:off x="548640" y="5577840"/>
-            <a:ext cx="10972800" cy="457200"/>
-          </a:xfrm>
-          <a:prstGeom prst="rect">
-            <a:avLst/>
-          </a:prstGeom>
-          <a:noFill/>
-        </p:spPr>
-        <p:txBody>
-          <a:bodyPr wrap="square">
-            <a:spAutoFit/>
-          </a:bodyPr>
-          <a:lstStyle/>
-          <a:p>
-            <a:pPr algn="ctr"/>
-            <a:r>
-              <a:rPr sz="1500" b="0" i="0">
-                <a:solidFill>
-                  <a:srgbClr val="8899BB"/>
-                </a:solidFill>
-              </a:rPr>
-              <a:t>Node.js  ·  Express  ·  Anthropic SDK  ·  Vercel</a:t>
+              <a:t>질문이 있으시면 말씀해 주세요</a:t>
             </a:r>
           </a:p>
         </p:txBody>

</xml_diff>